<commit_message>
chore: update latest digest + pptx
</commit_message>
<xml_diff>
--- a/docs/latest-digest.pptx
+++ b/docs/latest-digest.pptx
@@ -3534,7 +3534,7 @@
                   <a:srgbClr val="1A2332"/>
                 </a:solidFill>
               </a:rPr>
-              <a:t>EN: It is crucial for healthcare providers to enhance patient education regarding colorectal cancer risks in IBD to improve early detection and management. </a:t>
+              <a:t>EN: Increased awareness and education about colorectal cancer risks in IBD patients can lead to earlier detection and better management outcomes. </a:t>
             </a:r>
             <a:endParaRPr lang="en-US" sz="1000" dirty="0"/>
           </a:p>
@@ -3551,7 +3551,7 @@
                   <a:srgbClr val="1A2332"/>
                 </a:solidFill>
               </a:rPr>
-              <a:t>ZH: 醫療提供者必須加強對IBD患者關於結腸直腸癌風險的教育，以改善早期檢測和管理。</a:t>
+              <a:t>ZH: 提高IBD患者對大腸癌風險的認知和教育可以促進早期檢測和改善管理結果。</a:t>
             </a:r>
             <a:endParaRPr lang="en-US" sz="1000" dirty="0"/>
           </a:p>
@@ -3694,7 +3694,7 @@
                   <a:srgbClr val="1A2332"/>
                 </a:solidFill>
               </a:rPr>
-              <a:t>EN: Future research should focus on developing targeted educational interventions to raise awareness among IBD patients about their cancer risks. </a:t>
+              <a:t>EN: Future research should focus on developing targeted educational interventions to enhance patient knowledge about colorectal cancer risks. </a:t>
             </a:r>
             <a:endParaRPr lang="en-US" sz="1000" dirty="0"/>
           </a:p>
@@ -3711,7 +3711,7 @@
                   <a:srgbClr val="1A2332"/>
                 </a:solidFill>
               </a:rPr>
-              <a:t>ZH: 未來的研究應著重於開發針對性的教育干預措施，以提高IBD患者對其癌症風險的認識。</a:t>
+              <a:t>ZH: 未來的研究應著重於開發針對性的教育干預措施，以增強患者對大腸癌風險的認知。</a:t>
             </a:r>
             <a:endParaRPr lang="en-US" sz="1000" dirty="0"/>
           </a:p>
@@ -4058,7 +4058,7 @@
                 <a:ea typeface="Arial" pitchFamily="34" charset="-122"/>
                 <a:cs typeface="Arial" pitchFamily="34" charset="-120"/>
               </a:rPr>
-              <a:t>Thlaspi arvense (TA) significantly reduces disease severity in a mouse model of colitis-associated colorectal cancer (CAC).</a:t>
+              <a:t>Thlaspi arvense (TA) significantly reduces colitis-associated colorectal tumorigenesis by inhibiting neutrophil recruitment.</a:t>
             </a:r>
             <a:endParaRPr lang="en-US" sz="1000" dirty="0"/>
           </a:p>
@@ -4079,7 +4079,7 @@
                 <a:ea typeface="Arial" pitchFamily="34" charset="-122"/>
                 <a:cs typeface="Arial" pitchFamily="34" charset="-120"/>
               </a:rPr>
-              <a:t>TA treatment restores mucosal integrity and increases the expression of tight junction proteins ZO-1 and Claudin-1.</a:t>
+              <a:t>TA treatment restores mucosal integrity and upregulates tight junction proteins ZO-1 and Claudin-1.</a:t>
             </a:r>
             <a:endParaRPr lang="en-US" sz="1000" dirty="0"/>
           </a:p>
@@ -4100,7 +4100,7 @@
                 <a:ea typeface="Arial" pitchFamily="34" charset="-122"/>
                 <a:cs typeface="Arial" pitchFamily="34" charset="-120"/>
               </a:rPr>
-              <a:t>TA suppresses neutrophil recruitment by inhibiting the NOD/NF-κB signaling pathway, leading to decreased levels of neutrophil chemoattractants CXCL1 and CXCL2.</a:t>
+              <a:t>The mechanism of action involves suppression of the NOD/NF-κB signaling pathway, leading to decreased production of neutrophil chemoattractants CXCL1 and CXCL2.</a:t>
             </a:r>
             <a:endParaRPr lang="en-US" sz="1000" dirty="0"/>
           </a:p>
@@ -4182,7 +4182,7 @@
                 <a:ea typeface="Microsoft JhengHei" pitchFamily="34" charset="-122"/>
                 <a:cs typeface="Microsoft JhengHei" pitchFamily="34" charset="-120"/>
               </a:rPr>
-              <a:t>Thlaspi arvense (TA) 在大腸炎相關結腸直腸癌 (CAC) 的小鼠模型中顯著減少疾病嚴重性。</a:t>
+              <a:t>Thlaspi arvense (TA) 透過抑制中性粒細胞招募顯著減少與結腸炎相關的結直腸腫瘤形成。</a:t>
             </a:r>
             <a:endParaRPr lang="en-US" sz="1000" dirty="0"/>
           </a:p>
@@ -4203,7 +4203,7 @@
                 <a:ea typeface="Microsoft JhengHei" pitchFamily="34" charset="-122"/>
                 <a:cs typeface="Microsoft JhengHei" pitchFamily="34" charset="-120"/>
               </a:rPr>
-              <a:t>TA 治療恢復了黏膜完整性並增加了緊密連接蛋白 ZO-1 和 Claudin-1 的表達。</a:t>
+              <a:t>TA 治療恢復了黏膜完整性並上調緊密連接蛋白 ZO-1 和 Claudin-1。</a:t>
             </a:r>
             <a:endParaRPr lang="en-US" sz="1000" dirty="0"/>
           </a:p>
@@ -4224,7 +4224,7 @@
                 <a:ea typeface="Microsoft JhengHei" pitchFamily="34" charset="-122"/>
                 <a:cs typeface="Microsoft JhengHei" pitchFamily="34" charset="-120"/>
               </a:rPr>
-              <a:t>TA 通過抑制 NOD/NF-κB 信號通路來抑制中性粒細胞的招募，從而降低中性粒細胞化學吸引因子 CXCL1 和 CXCL2 的水平。</a:t>
+              <a:t>其作用機制涉及抑制 NOD/NF-κB 信號通路，導致中性粒細胞趨化因子 CXCL1 和 CXCL2 的產生減少。</a:t>
             </a:r>
             <a:endParaRPr lang="en-US" sz="1000" dirty="0"/>
           </a:p>
@@ -4602,7 +4602,7 @@
                   <a:srgbClr val="1A2332"/>
                 </a:solidFill>
               </a:rPr>
-              <a:t>EN: This study highlights the potential of Thlaspi arvense as a natural therapeutic agent to mitigate inflammation-driven tumorigenesis in colitis-associated colorectal cancer. </a:t>
+              <a:t>EN: This study highlights the potential of Thlaspi arvense as a natural therapeutic agent for preventing colitis-associated colorectal cancer by targeting neutrophil-driven inflammation. </a:t>
             </a:r>
             <a:endParaRPr lang="en-US" sz="1000" dirty="0"/>
           </a:p>
@@ -4619,7 +4619,7 @@
                   <a:srgbClr val="1A2332"/>
                 </a:solidFill>
               </a:rPr>
-              <a:t>ZH: 本研究強調了 Thlaspi arvense 作為天然治療劑的潛力，以減輕大腸炎相關結腸直腸癌中的炎症驅動腫瘤生成。</a:t>
+              <a:t>ZH: 本研究強調了 Thlaspi arvense 作為一種天然治療劑在預防與結腸炎相關的結直腸癌中的潛力，通過針對中性粒細胞驅動的炎症。</a:t>
             </a:r>
             <a:endParaRPr lang="en-US" sz="1000" dirty="0"/>
           </a:p>
@@ -4779,7 +4779,7 @@
                   <a:srgbClr val="1A2332"/>
                 </a:solidFill>
               </a:rPr>
-              <a:t>ZH: 未來的研究應集中於臨床試驗，以驗證 Thlaspi arvense 在大腸炎相關結腸直腸癌患者中的療效。</a:t>
+              <a:t>ZH: 未來的研究應集中於臨床試驗，以驗證 Thlaspi arvense 在與結腸炎相關的結直腸癌患者中的療效。</a:t>
             </a:r>
             <a:endParaRPr lang="en-US" sz="1000" dirty="0"/>
           </a:p>
@@ -5126,7 +5126,7 @@
                 <a:ea typeface="Arial" pitchFamily="34" charset="-122"/>
                 <a:cs typeface="Arial" pitchFamily="34" charset="-120"/>
               </a:rPr>
-              <a:t>Alpha-1 antitrypsin (A1AT) promotes liver metastasis in colorectal cancer (CRC) through neutrophil extracellular traps (NETs) and CCDC25.</a:t>
+              <a:t>Alpha-1 antitrypsin (A1AT) promotes liver metastasis of colorectal cancer (CRC) through neutrophil extracellular traps (NETs) and CCDC25.</a:t>
             </a:r>
             <a:endParaRPr lang="en-US" sz="1000" dirty="0"/>
           </a:p>
@@ -5168,7 +5168,7 @@
                 <a:ea typeface="Arial" pitchFamily="34" charset="-122"/>
                 <a:cs typeface="Arial" pitchFamily="34" charset="-120"/>
               </a:rPr>
-              <a:t>The A1AT-mediated upregulation of CCDC25 enhances CRC cell migration and invasion via the ILK-RAC1-CDC42 signaling cascade.</a:t>
+              <a:t>The interaction between A1AT and CCDC25 activates the ILK-RAC1-CDC42 signaling cascade, enhancing CRC cell migration and invasion.</a:t>
             </a:r>
             <a:endParaRPr lang="en-US" sz="1000" dirty="0"/>
           </a:p>
@@ -5292,7 +5292,7 @@
                 <a:ea typeface="Microsoft JhengHei" pitchFamily="34" charset="-122"/>
                 <a:cs typeface="Microsoft JhengHei" pitchFamily="34" charset="-120"/>
               </a:rPr>
-              <a:t>A1AT介導的CCDC25上調通過ILK-RAC1-CDC42信號通路增強CRC細胞的遷移和侵襲能力。</a:t>
+              <a:t>A1AT與CCDC25的相互作用激活ILK-RAC1-CDC42信號通路，增強CRC細胞的遷移和侵襲能力。</a:t>
             </a:r>
             <a:endParaRPr lang="en-US" sz="1000" dirty="0"/>
           </a:p>
@@ -5670,7 +5670,7 @@
                   <a:srgbClr val="1A2332"/>
                 </a:solidFill>
               </a:rPr>
-              <a:t>EN: The findings suggest that targeting the A1AT-NET-CCDC25 axis may provide new therapeutic strategies for managing liver metastasis in colorectal cancer patients. </a:t>
+              <a:t>EN: The findings highlight A1AT as a potential biomarker for liver metastasis in CRC patients, suggesting its role in disease progression. </a:t>
             </a:r>
             <a:endParaRPr lang="en-US" sz="1000" dirty="0"/>
           </a:p>
@@ -5687,7 +5687,7 @@
                   <a:srgbClr val="1A2332"/>
                 </a:solidFill>
               </a:rPr>
-              <a:t>ZH: 研究結果表明，針對A1AT-NET-CCDC25軸可能為管理結直腸癌患者的肝轉移提供新的治療策略。</a:t>
+              <a:t>ZH: 研究結果突顯A1AT作為CRC患者肝轉移的潛在生物標誌物，暗示其在疾病進展中的作用。</a:t>
             </a:r>
             <a:endParaRPr lang="en-US" sz="1000" dirty="0"/>
           </a:p>
@@ -5830,7 +5830,7 @@
                   <a:srgbClr val="1A2332"/>
                 </a:solidFill>
               </a:rPr>
-              <a:t>EN: Future studies should focus on developing inhibitors that disrupt the A1AT-NET-CCDC25 pathway to reduce metastatic spread. </a:t>
+              <a:t>EN: Future studies should explore the therapeutic targeting of the A1AT-NET-CCDC25 axis to inhibit CRC liver metastasis. </a:t>
             </a:r>
             <a:endParaRPr lang="en-US" sz="1000" dirty="0"/>
           </a:p>
@@ -5847,7 +5847,7 @@
                   <a:srgbClr val="1A2332"/>
                 </a:solidFill>
               </a:rPr>
-              <a:t>ZH: 未來的研究應集中於開發破壞A1AT-NET-CCDC25通路的抑制劑，以減少轉移擴散。</a:t>
+              <a:t>ZH: 未來的研究應探討針對A1AT-NET-CCDC25軸的治療策略，以抑制CRC肝轉移。</a:t>
             </a:r>
             <a:endParaRPr lang="en-US" sz="1000" dirty="0"/>
           </a:p>
@@ -6257,7 +6257,7 @@
                 <a:ea typeface="Arial" pitchFamily="34" charset="-122"/>
                 <a:cs typeface="Arial" pitchFamily="34" charset="-120"/>
               </a:rPr>
-              <a:t>Single-photon emission computed tomography imaging indicated rapid metabolism of the radiotracers in vivo, leading to no tumor retention.</a:t>
+              <a:t>Single-photon emission computed tomography imaging indicated rapid metabolism of the radiotracers, leading to no tumor retention.</a:t>
             </a:r>
             <a:endParaRPr lang="en-US" sz="1000" dirty="0"/>
           </a:p>
@@ -6278,7 +6278,7 @@
                 <a:ea typeface="Arial" pitchFamily="34" charset="-122"/>
                 <a:cs typeface="Arial" pitchFamily="34" charset="-120"/>
               </a:rPr>
-              <a:t>Further improvements in inhibitory activity and stability are necessary for effective radiotracer development.</a:t>
+              <a:t>Further enhancements in inhibitory activity and stability are necessary for effective radiotracer development.</a:t>
             </a:r>
             <a:endParaRPr lang="en-US" sz="1000" dirty="0"/>
           </a:p>
@@ -6360,7 +6360,7 @@
                 <a:ea typeface="Microsoft JhengHei" pitchFamily="34" charset="-122"/>
                 <a:cs typeface="Microsoft JhengHei" pitchFamily="34" charset="-120"/>
               </a:rPr>
-              <a:t>成功對異構體的closo-dicarbadodecaborane(12)基雙COX-2/5-LO抑制劑進行了放射性碘標記。</a:t>
+              <a:t>成功對異構體的closo-dicarbadodecaborane(12)基雙COX-2/5-LO抑制劑進行放射碘標記。</a:t>
             </a:r>
             <a:endParaRPr lang="en-US" sz="1000" dirty="0"/>
           </a:p>
@@ -6381,7 +6381,7 @@
                 <a:ea typeface="Microsoft JhengHei" pitchFamily="34" charset="-122"/>
                 <a:cs typeface="Microsoft JhengHei" pitchFamily="34" charset="-120"/>
               </a:rPr>
-              <a:t>碘化衍生物在體外對5-LO的抑制活性顯著高於對COX-2的抑制活性。</a:t>
+              <a:t>碘化衍生物在體外對5-LO的抑制效力顯著高於對COX-2的抑制效力。</a:t>
             </a:r>
             <a:endParaRPr lang="en-US" sz="1000" dirty="0"/>
           </a:p>
@@ -6402,7 +6402,7 @@
                 <a:ea typeface="Microsoft JhengHei" pitchFamily="34" charset="-122"/>
                 <a:cs typeface="Microsoft JhengHei" pitchFamily="34" charset="-120"/>
               </a:rPr>
-              <a:t>放射性示蹤劑的細胞攝取受腫瘤細胞中5-LO表達的影響，但對炎症細胞則無影響。</a:t>
+              <a:t>放射性示蹤劑的細胞攝取受到腫瘤細胞中5-LO表達的影響，但不受炎症細胞的影響。</a:t>
             </a:r>
             <a:endParaRPr lang="en-US" sz="1000" dirty="0"/>
           </a:p>
@@ -6423,7 +6423,7 @@
                 <a:ea typeface="Microsoft JhengHei" pitchFamily="34" charset="-122"/>
                 <a:cs typeface="Microsoft JhengHei" pitchFamily="34" charset="-120"/>
               </a:rPr>
-              <a:t>單光子發射計算機斷層成像顯示，放射性示蹤劑在體內迅速代謝，導致無腫瘤保留。</a:t>
+              <a:t>單光子發射計算機斷層成像顯示放射性示蹤劑迅速代謝，導致無腫瘤滯留。</a:t>
             </a:r>
             <a:endParaRPr lang="en-US" sz="1000" dirty="0"/>
           </a:p>
@@ -6444,7 +6444,7 @@
                 <a:ea typeface="Microsoft JhengHei" pitchFamily="34" charset="-122"/>
                 <a:cs typeface="Microsoft JhengHei" pitchFamily="34" charset="-120"/>
               </a:rPr>
-              <a:t>需要進一步改善抑制活性和穩定性，以開發有效的放射性示蹤劑。</a:t>
+              <a:t>需要進一步提高抑制活性和穩定性，以開發有效的放射性示蹤劑。</a:t>
             </a:r>
             <a:endParaRPr lang="en-US" sz="1000" dirty="0"/>
           </a:p>
@@ -6822,7 +6822,7 @@
                   <a:srgbClr val="1A2332"/>
                 </a:solidFill>
               </a:rPr>
-              <a:t>EN: The study highlights the potential of COX-2 and 5-LO as molecular targets for radiotracer development in cancer imaging. </a:t>
+              <a:t>EN: The study highlights the potential of dual COX-2/5-LO inhibitors as radiotracers for imaging in cancer. </a:t>
             </a:r>
             <a:endParaRPr lang="en-US" sz="1000" dirty="0"/>
           </a:p>
@@ -6839,7 +6839,7 @@
                   <a:srgbClr val="1A2332"/>
                 </a:solidFill>
               </a:rPr>
-              <a:t>ZH: 本研究突顯了COX-2和5-LO作為癌症影像學中放射性示蹤劑開發的分子靶點的潛力。</a:t>
+              <a:t>ZH: 本研究強調了雙COX-2/5-LO抑制劑作為癌症成像放射性示蹤劑的潛力。</a:t>
             </a:r>
             <a:endParaRPr lang="en-US" sz="1000" dirty="0"/>
           </a:p>
@@ -6982,7 +6982,7 @@
                   <a:srgbClr val="1A2332"/>
                 </a:solidFill>
               </a:rPr>
-              <a:t>EN: Future research should focus on enhancing the stability and inhibitory activity of these radiotracers for better clinical applicability. </a:t>
+              <a:t>EN: Future research should focus on enhancing the stability and efficacy of these radiotracers for better clinical application. </a:t>
             </a:r>
             <a:endParaRPr lang="en-US" sz="1000" dirty="0"/>
           </a:p>
@@ -6999,7 +6999,7 @@
                   <a:srgbClr val="1A2332"/>
                 </a:solidFill>
               </a:rPr>
-              <a:t>ZH: 未來的研究應集中於提高這些放射性示蹤劑的穩定性和抑制活性，以提高其臨床應用性。</a:t>
+              <a:t>ZH: 未來的研究應集中於提高這些放射性示蹤劑的穩定性和效能，以便更好地應用於臨床。</a:t>
             </a:r>
             <a:endParaRPr lang="en-US" sz="1000" dirty="0"/>
           </a:p>
@@ -7346,7 +7346,7 @@
                 <a:ea typeface="Arial" pitchFamily="34" charset="-122"/>
                 <a:cs typeface="Arial" pitchFamily="34" charset="-120"/>
               </a:rPr>
-              <a:t>Sanghuangporus vaninii (SH) extract demonstrates significant anti-tumor effects in colitis-associated colorectal cancer (CAC) models.</a:t>
+              <a:t>Sanghuangporus vaninii (SH) extract significantly inhibits colitis-associated colorectal cancer (CAC) in a mouse model.</a:t>
             </a:r>
             <a:endParaRPr lang="en-US" sz="1000" dirty="0"/>
           </a:p>
@@ -7367,7 +7367,7 @@
                 <a:ea typeface="Arial" pitchFamily="34" charset="-122"/>
                 <a:cs typeface="Arial" pitchFamily="34" charset="-120"/>
               </a:rPr>
-              <a:t>SH treatment leads to a dose-dependent reduction in tumor number and improvement in overall health indicators in AOM/DSS-induced CAC mice.</a:t>
+              <a:t>SH treatment improves body weight, colon length, and survival rates while reducing tumor numbers and disease activity index.</a:t>
             </a:r>
             <a:endParaRPr lang="en-US" sz="1000" dirty="0"/>
           </a:p>
@@ -7388,7 +7388,7 @@
                 <a:ea typeface="Arial" pitchFamily="34" charset="-122"/>
                 <a:cs typeface="Arial" pitchFamily="34" charset="-120"/>
               </a:rPr>
-              <a:t>The PPARγ/NF-κB axis is identified as a key pathway through which SH exerts its therapeutic effects by modulating inflammatory responses.</a:t>
+              <a:t>The extract rebalances cytokine profiles by suppressing pro-inflammatory cytokines and enhancing anti-inflammatory cytokines.</a:t>
             </a:r>
             <a:endParaRPr lang="en-US" sz="1000" dirty="0"/>
           </a:p>
@@ -7409,7 +7409,7 @@
                 <a:ea typeface="Arial" pitchFamily="34" charset="-122"/>
                 <a:cs typeface="Arial" pitchFamily="34" charset="-120"/>
               </a:rPr>
-              <a:t>SH enhances macrophage polarization towards an anti-inflammatory M2 phenotype, contributing to tumor suppression.</a:t>
+              <a:t>SH's anti-tumor effects are mediated through the PPARγ/NF-κB axis, leading to cell cycle arrest and macrophage reprogramming.</a:t>
             </a:r>
             <a:endParaRPr lang="en-US" sz="1000" dirty="0"/>
           </a:p>
@@ -7430,7 +7430,7 @@
                 <a:ea typeface="Arial" pitchFamily="34" charset="-122"/>
                 <a:cs typeface="Arial" pitchFamily="34" charset="-120"/>
               </a:rPr>
-              <a:t>In vitro studies confirm that SH inhibits CRC cell proliferation and induces cell cycle arrest.</a:t>
+              <a:t>The study highlights the dual mechanism of SH in directly targeting tumor cells and modulating tumor-associated macrophages.</a:t>
             </a:r>
             <a:endParaRPr lang="en-US" sz="1000" dirty="0"/>
           </a:p>
@@ -7512,7 +7512,7 @@
                 <a:ea typeface="Microsoft JhengHei" pitchFamily="34" charset="-122"/>
                 <a:cs typeface="Microsoft JhengHei" pitchFamily="34" charset="-120"/>
               </a:rPr>
-              <a:t>桑黃（SH）提取物在結腸炎相關結直腸癌（CAC）模型中顯示出顯著的抗腫瘤效果。</a:t>
+              <a:t>桑黃（SH）提取物顯著抑制結腸炎相關結直腸癌（CAC）的小鼠模型。</a:t>
             </a:r>
             <a:endParaRPr lang="en-US" sz="1000" dirty="0"/>
           </a:p>
@@ -7533,7 +7533,7 @@
                 <a:ea typeface="Microsoft JhengHei" pitchFamily="34" charset="-122"/>
                 <a:cs typeface="Microsoft JhengHei" pitchFamily="34" charset="-120"/>
               </a:rPr>
-              <a:t>SH治療在AOM/DSS誘導的CAC小鼠中導致腫瘤數量的劑量依賴性減少，並改善整體健康指標。</a:t>
+              <a:t>SH治療改善體重、結腸長度和存活率，同時減少腫瘤數量和疾病活動指數。</a:t>
             </a:r>
             <a:endParaRPr lang="en-US" sz="1000" dirty="0"/>
           </a:p>
@@ -7554,7 +7554,7 @@
                 <a:ea typeface="Microsoft JhengHei" pitchFamily="34" charset="-122"/>
                 <a:cs typeface="Microsoft JhengHei" pitchFamily="34" charset="-120"/>
               </a:rPr>
-              <a:t>PPARγ/NF-κB軸被確定為SH發揮治療效果的關鍵通路，通過調節炎症反應。</a:t>
+              <a:t>該提取物通過抑制促炎細胞因子和增強抗炎細胞因子來重新平衡細胞因子譜。</a:t>
             </a:r>
             <a:endParaRPr lang="en-US" sz="1000" dirty="0"/>
           </a:p>
@@ -7575,7 +7575,7 @@
                 <a:ea typeface="Microsoft JhengHei" pitchFamily="34" charset="-122"/>
                 <a:cs typeface="Microsoft JhengHei" pitchFamily="34" charset="-120"/>
               </a:rPr>
-              <a:t>SH促進巨噬細胞極化向抗炎的M2表型，對腫瘤抑制有貢獻。</a:t>
+              <a:t>SH的抗腫瘤效果通過PPARγ/NF-κB軸介導，導致細胞週期停滯和巨噬細胞重編程。</a:t>
             </a:r>
             <a:endParaRPr lang="en-US" sz="1000" dirty="0"/>
           </a:p>
@@ -7596,7 +7596,7 @@
                 <a:ea typeface="Microsoft JhengHei" pitchFamily="34" charset="-122"/>
                 <a:cs typeface="Microsoft JhengHei" pitchFamily="34" charset="-120"/>
               </a:rPr>
-              <a:t>體外研究確認SH抑制CRC細胞增殖並誘導細胞週期停滯。</a:t>
+              <a:t>該研究突顯了SH在直接針對腫瘤細胞和調節腫瘤相關巨噬細胞方面的雙重機制。</a:t>
             </a:r>
             <a:endParaRPr lang="en-US" sz="1000" dirty="0"/>
           </a:p>
@@ -7974,7 +7974,7 @@
                   <a:srgbClr val="1A2332"/>
                 </a:solidFill>
               </a:rPr>
-              <a:t>EN: The findings suggest that Sanghuangporus vaninii could be a promising therapeutic agent for patients with colitis-associated colorectal cancer by targeting inflammatory pathways. </a:t>
+              <a:t>EN: The findings suggest that Sanghuangporus vaninii could be a promising therapeutic agent for colitis-associated colorectal cancer by targeting both tumor cells and the inflammatory microenvironment. </a:t>
             </a:r>
             <a:endParaRPr lang="en-US" sz="1000" dirty="0"/>
           </a:p>
@@ -7991,7 +7991,7 @@
                   <a:srgbClr val="1A2332"/>
                 </a:solidFill>
               </a:rPr>
-              <a:t>ZH: 研究結果表明，桑黃可能成為結腸炎相關結直腸癌患者的一種有前景的治療藥物，通過針對炎症通路來發揮作用。</a:t>
+              <a:t>ZH: 研究結果表明，桑黃可能成為結腸炎相關結直腸癌的有前景的治療藥物，通過同時針對腫瘤細胞和炎症微環境。</a:t>
             </a:r>
             <a:endParaRPr lang="en-US" sz="1000" dirty="0"/>
           </a:p>
@@ -8134,7 +8134,7 @@
                   <a:srgbClr val="1A2332"/>
                 </a:solidFill>
               </a:rPr>
-              <a:t>EN: Future studies should focus on clinical trials to validate the efficacy of SH in human subjects and explore its potential combination with other therapies. </a:t>
+              <a:t>EN: Future research should focus on clinical trials to validate the efficacy of SH in human subjects and explore its potential synergistic effects with other cancer therapies. </a:t>
             </a:r>
             <a:endParaRPr lang="en-US" sz="1000" dirty="0"/>
           </a:p>
@@ -8151,7 +8151,7 @@
                   <a:srgbClr val="1A2332"/>
                 </a:solidFill>
               </a:rPr>
-              <a:t>ZH: 未來的研究應著重於臨床試驗，以驗證SH在人體中的療效，並探索其與其他療法的潛在聯合使用。</a:t>
+              <a:t>ZH: 未來的研究應集中於臨床試驗，以驗證SH在人體中的療效，並探索其與其他癌症療法的潛在協同作用。</a:t>
             </a:r>
             <a:endParaRPr lang="en-US" sz="1000" dirty="0"/>
           </a:p>
@@ -8498,7 +8498,7 @@
                 <a:ea typeface="Arial" pitchFamily="34" charset="-122"/>
                 <a:cs typeface="Arial" pitchFamily="34" charset="-120"/>
               </a:rPr>
-              <a:t>Peritoneal metastatic colorectal cancer (pmCRC) shows significantly poorer outcomes compared to other metastatic CRC subtypes.</a:t>
+              <a:t>Peritoneal metastatic colorectal cancer (pmCRC) shows significantly worse outcomes compared to other metastatic colorectal cancer subtypes.</a:t>
             </a:r>
             <a:endParaRPr lang="en-US" sz="1000" dirty="0"/>
           </a:p>
@@ -8540,7 +8540,7 @@
                 <a:ea typeface="Arial" pitchFamily="34" charset="-122"/>
                 <a:cs typeface="Arial" pitchFamily="34" charset="-120"/>
               </a:rPr>
-              <a:t>Preclinical analysis using patient-derived xenografts demonstrates the efficacy of PARP inhibitors in targeted treatment strategies.</a:t>
+              <a:t>Preclinical analysis using patient-derived xenografts demonstrates the efficacy of PARP inhibitors in these defined subgroups.</a:t>
             </a:r>
             <a:endParaRPr lang="en-US" sz="1000" dirty="0"/>
           </a:p>
@@ -8622,7 +8622,7 @@
                 <a:ea typeface="Microsoft JhengHei" pitchFamily="34" charset="-122"/>
                 <a:cs typeface="Microsoft JhengHei" pitchFamily="34" charset="-120"/>
               </a:rPr>
-              <a:t>腹膜轉移性結腸直腸癌（pmCRC）的預後顯著差於其他轉移性結腸直腸癌亞型。</a:t>
+              <a:t>腹膜轉移性結直腸癌（pmCRC）的預後顯著差於其他轉移性結直腸癌亞型。</a:t>
             </a:r>
             <a:endParaRPr lang="en-US" sz="1000" dirty="0"/>
           </a:p>
@@ -8664,7 +8664,7 @@
                 <a:ea typeface="Microsoft JhengHei" pitchFamily="34" charset="-122"/>
                 <a:cs typeface="Microsoft JhengHei" pitchFamily="34" charset="-120"/>
               </a:rPr>
-              <a:t>使用患者衍生的異種移植進行的前臨床分析顯示PARP抑制劑在靶向治療策略中的有效性。</a:t>
+              <a:t>使用患者衍生的異種移植進行的前臨床分析顯示PARP抑制劑在這些定義的亞群中的療效。</a:t>
             </a:r>
             <a:endParaRPr lang="en-US" sz="1000" dirty="0"/>
           </a:p>
@@ -9927,7 +9927,7 @@
                   <a:srgbClr val="1A2332"/>
                 </a:solidFill>
               </a:rPr>
-              <a:t>EN: The findings suggest that molecular profiling of pmCRC patients could guide the use of PARP inhibitors, potentially improving treatment outcomes. </a:t>
+              <a:t>EN: The findings suggest that molecular profiling of pmCRC patients could guide personalized treatment strategies using PARP inhibitors. </a:t>
             </a:r>
             <a:endParaRPr lang="en-US" sz="1000" dirty="0"/>
           </a:p>
@@ -9944,7 +9944,7 @@
                   <a:srgbClr val="1A2332"/>
                 </a:solidFill>
               </a:rPr>
-              <a:t>ZH: 這些發現表明，對pmCRC患者進行分子分型可能有助於指導PARP抑制劑的使用，從而改善治療效果。</a:t>
+              <a:t>ZH: 研究結果表明，對pmCRC患者進行分子分型可以指導使用PARP抑制劑的個性化治療策略。</a:t>
             </a:r>
             <a:endParaRPr lang="en-US" sz="1000" dirty="0"/>
           </a:p>
@@ -10087,7 +10087,7 @@
                   <a:srgbClr val="1A2332"/>
                 </a:solidFill>
               </a:rPr>
-              <a:t>EN: Future research should focus on clinical trials to validate the efficacy of PARP inhibitors in identified pmCRC subgroups. </a:t>
+              <a:t>EN: Future studies should focus on clinical trials to validate the effectiveness of PARP inhibitors in the identified molecular subgroups of pmCRC. </a:t>
             </a:r>
             <a:endParaRPr lang="en-US" sz="1000" dirty="0"/>
           </a:p>
@@ -10104,7 +10104,7 @@
                   <a:srgbClr val="1A2332"/>
                 </a:solidFill>
               </a:rPr>
-              <a:t>ZH: 未來的研究應集中於臨床試驗，以驗證PARP抑制劑在已確定的pmCRC亞群中的有效性。</a:t>
+              <a:t>ZH: 未來的研究應集中於臨床試驗，以驗證PARP抑制劑在pmCRC中識別的分子亞群的有效性。</a:t>
             </a:r>
             <a:endParaRPr lang="en-US" sz="1000" dirty="0"/>
           </a:p>
@@ -10472,7 +10472,7 @@
                 <a:ea typeface="Arial" pitchFamily="34" charset="-122"/>
                 <a:cs typeface="Arial" pitchFamily="34" charset="-120"/>
               </a:rPr>
-              <a:t>In vivo studies confirmed that ALC effectively suppresses the progression of colorectal cancer.</a:t>
+              <a:t>In vivo studies confirmed that ALC effectively suppresses tumor development in nude mice.</a:t>
             </a:r>
             <a:endParaRPr lang="en-US" sz="1000" dirty="0"/>
           </a:p>
@@ -10575,7 +10575,7 @@
                 <a:ea typeface="Microsoft JhengHei" pitchFamily="34" charset="-122"/>
                 <a:cs typeface="Microsoft JhengHei" pitchFamily="34" charset="-120"/>
               </a:rPr>
-              <a:t>乙酰左旋肉鹼（ALC）對大腸癌腫瘤生長具有顯著的抑制作用。</a:t>
+              <a:t>乙酰-L-肉鹼（ALC）對大腸癌腫瘤生長具有顯著的抑制作用。</a:t>
             </a:r>
             <a:endParaRPr lang="en-US" sz="1000" dirty="0"/>
           </a:p>
@@ -10596,7 +10596,7 @@
                 <a:ea typeface="Microsoft JhengHei" pitchFamily="34" charset="-122"/>
                 <a:cs typeface="Microsoft JhengHei" pitchFamily="34" charset="-120"/>
               </a:rPr>
-              <a:t>體內研究證實ALC有效抑制大腸癌的進展。</a:t>
+              <a:t>體內研究證實ALC能有效抑制裸鼠的腫瘤發展。</a:t>
             </a:r>
             <a:endParaRPr lang="en-US" sz="1000" dirty="0"/>
           </a:p>
@@ -10967,7 +10967,7 @@
                   <a:srgbClr val="1A2332"/>
                 </a:solidFill>
               </a:rPr>
-              <a:t>ZH: 這些發現表明ALC可能成為大腸癌治療的潛在療法。</a:t>
+              <a:t>ZH: 研究結果表明，ALC可能成為大腸癌治療的潛在藥物。</a:t>
             </a:r>
             <a:endParaRPr lang="en-US" sz="1000" dirty="0"/>
           </a:p>
@@ -11110,7 +11110,7 @@
                   <a:srgbClr val="1A2332"/>
                 </a:solidFill>
               </a:rPr>
-              <a:t>EN: Future research should focus on elucidating the specific metabolic pathways affected by ALC. </a:t>
+              <a:t>EN: Future studies should explore the specific metabolic pathways influenced by ALC in colorectal cancer. </a:t>
             </a:r>
             <a:endParaRPr lang="en-US" sz="1000" dirty="0"/>
           </a:p>
@@ -11127,7 +11127,7 @@
                   <a:srgbClr val="1A2332"/>
                 </a:solidFill>
               </a:rPr>
-              <a:t>ZH: 未來的研究應著重於闡明ALC影響的具體代謝途徑。</a:t>
+              <a:t>ZH: 未來的研究應該探討ALC在大腸癌中影響的具體代謝途徑。</a:t>
             </a:r>
             <a:endParaRPr lang="en-US" sz="1000" dirty="0"/>
           </a:p>
@@ -11398,7 +11398,7 @@
                   <a:srgbClr val="E8F0F2"/>
                 </a:solidFill>
               </a:rPr>
-              <a:t>1. **腫瘤微環境與轉移的關聯性**  </a:t>
+              <a:t>1. **新興生物標記的預後價值**  </a:t>
             </a:r>
             <a:endParaRPr lang="en-US" sz="1000" dirty="0"/>
           </a:p>
@@ -11415,7 +11415,7 @@
                   <a:srgbClr val="E8F0F2"/>
                 </a:solidFill>
               </a:rPr>
-              <a:t>   The inflammatory tumor microenvironment plays a critical role in promoting metastasis in colorectal cancer, particularly through mechanisms involving neutrophil infiltration.  </a:t>
+              <a:t>   The systemic immune-inflammation index (SII) has emerged as a promising prognostic biomarker in colorectal cancer, highlighting the importance of systemic inflammation in cancer progression.  </a:t>
             </a:r>
             <a:endParaRPr lang="en-US" sz="1000" dirty="0"/>
           </a:p>
@@ -11432,7 +11432,7 @@
                   <a:srgbClr val="E8F0F2"/>
                 </a:solidFill>
               </a:rPr>
-              <a:t>   腫瘤微環境中的炎症對於促進大腸癌轉移具有關鍵作用，特別是通過中性粒細胞浸潤的機制。</a:t>
+              <a:t>   系統性免疫-炎症指數（SII）作為一種有前景的預後生物標記，強調了系統性炎症在癌症進展中的重要性。</a:t>
             </a:r>
             <a:endParaRPr lang="en-US" sz="1000" dirty="0"/>
           </a:p>
@@ -11458,7 +11458,7 @@
                   <a:srgbClr val="E8F0F2"/>
                 </a:solidFill>
               </a:rPr>
-              <a:t>2. **系統性免疫炎症指數的預後價值**  </a:t>
+              <a:t>2. **腸道微生物與癌症的關聯**  </a:t>
             </a:r>
             <a:endParaRPr lang="en-US" sz="1000" dirty="0"/>
           </a:p>
@@ -11475,7 +11475,7 @@
                   <a:srgbClr val="E8F0F2"/>
                 </a:solidFill>
               </a:rPr>
-              <a:t>   The systemic immune-inflammation index (SII) has emerged as a significant prognostic biomarker for colorectal cancer, indicating its potential utility in clinical practice.  </a:t>
+              <a:t>   Studies indicate that specific gut microbiota, such as Parasutterella excrementihominis, can exacerbate colitis and promote colorectal cancer, suggesting a potential therapeutic target for inflammation-driven carcinogenesis.  </a:t>
             </a:r>
             <a:endParaRPr lang="en-US" sz="1000" dirty="0"/>
           </a:p>
@@ -11492,7 +11492,7 @@
                   <a:srgbClr val="E8F0F2"/>
                 </a:solidFill>
               </a:rPr>
-              <a:t>   系統性免疫炎症指數（SII）已成為大腸癌的重要預後生物標記，顯示其在臨床實踐中的潛在應用價值。</a:t>
+              <a:t>   研究表明，特定的腸道微生物如Parasutterella excrementihominis可能加劇結腸炎並促進結直腸癌，這提示了針對炎症驅動癌變的潛在治療靶點。</a:t>
             </a:r>
             <a:endParaRPr lang="en-US" sz="1000" dirty="0"/>
           </a:p>
@@ -11518,7 +11518,7 @@
                   <a:srgbClr val="E8F0F2"/>
                 </a:solidFill>
               </a:rPr>
-              <a:t>3. **炎症性腸病患者的癌症風險認知**  </a:t>
+              <a:t>3. **慢性炎症與腫瘤形成的關聯**  </a:t>
             </a:r>
             <a:endParaRPr lang="en-US" sz="1000" dirty="0"/>
           </a:p>
@@ -11535,7 +11535,7 @@
                   <a:srgbClr val="E8F0F2"/>
                 </a:solidFill>
               </a:rPr>
-              <a:t>   There is a notable gap in awareness regarding the risk of colorectal cancer among patients with inflammatory bowel disease, highlighting the need for better education and management strategies.  </a:t>
+              <a:t>   Chronic inflammation remains a critical driver of tumorigenesis in colitis-associated colorectal cancer, emphasizing the need for anti-inflammatory strategies in treatment.  </a:t>
             </a:r>
             <a:endParaRPr lang="en-US" sz="1000" dirty="0"/>
           </a:p>
@@ -11552,7 +11552,7 @@
                   <a:srgbClr val="E8F0F2"/>
                 </a:solidFill>
               </a:rPr>
-              <a:t>   炎症性腸病患者對大腸癌風險的認知存在明顯不足，突顯了改善教育和管理策略的必要性。</a:t>
+              <a:t>   慢性炎症仍然是結腸炎相關結直腸癌腫瘤形成的關鍵驅動因素，強調了在治療中需要採用抗炎策略。</a:t>
             </a:r>
             <a:endParaRPr lang="en-US" sz="1000" dirty="0"/>
           </a:p>
@@ -11578,7 +11578,7 @@
                   <a:srgbClr val="E8F0F2"/>
                 </a:solidFill>
               </a:rPr>
-              <a:t>4. **新療法的潛力**  </a:t>
+              <a:t>4. **肝轉移的炎症微環境**  </a:t>
             </a:r>
             <a:endParaRPr lang="en-US" sz="1000" dirty="0"/>
           </a:p>
@@ -11595,7 +11595,7 @@
                   <a:srgbClr val="E8F0F2"/>
                 </a:solidFill>
               </a:rPr>
-              <a:t>   Emerging therapeutic strategies targeting inflammation-driven colorectal carcinogenesis, such as the use of specific extracts and inhibitors, show promise in preclinical studies.  </a:t>
+              <a:t>   The inflammatory tumor microenvironment, particularly neutrophil infiltration, plays a significant role in promoting liver metastasis in colorectal cancer, indicating a need for targeted therapies.  </a:t>
             </a:r>
             <a:endParaRPr lang="en-US" sz="1000" dirty="0"/>
           </a:p>
@@ -11612,7 +11612,7 @@
                   <a:srgbClr val="E8F0F2"/>
                 </a:solidFill>
               </a:rPr>
-              <a:t>   針對炎症驅動的大腸癌發生的新療法，如特定提取物和抑制劑的使用，在前臨床研究中顯示出潛力。</a:t>
+              <a:t>   炎症腫瘤微環境，特別是中性粒細胞的浸潤，在促進結直腸癌肝轉移中起著重要作用，這表明需要針對性治療。</a:t>
             </a:r>
             <a:endParaRPr lang="en-US" sz="1000" dirty="0"/>
           </a:p>
@@ -11638,7 +11638,7 @@
                   <a:srgbClr val="E8F0F2"/>
                 </a:solidFill>
               </a:rPr>
-              <a:t>5. **PARP抑制劑的再利用**  </a:t>
+              <a:t>5. **傳統醫學的現代應用**  </a:t>
             </a:r>
             <a:endParaRPr lang="en-US" sz="1000" dirty="0"/>
           </a:p>
@@ -11655,7 +11655,7 @@
                   <a:srgbClr val="E8F0F2"/>
                 </a:solidFill>
               </a:rPr>
-              <a:t>   The repurposing of PARP inhibitors for molecularly defined subgroups of peritoneal metastatic colorectal cancer could provide new avenues for treatment in this challenging patient population.  </a:t>
+              <a:t>   The potential of traditional medicinal mushrooms like Sanghuangporus vaninii in treating colitis-associated colorectal cancer underscores the importance of integrating traditional and modern therapeutic approaches.  </a:t>
             </a:r>
             <a:endParaRPr lang="en-US" sz="1000" dirty="0"/>
           </a:p>
@@ -11672,7 +11672,7 @@
                   <a:srgbClr val="E8F0F2"/>
                 </a:solidFill>
               </a:rPr>
-              <a:t>   將PARP抑制劑再利用於分子特徵定義的腹膜轉移性大腸癌亞組，可能為這一挑戰性患者群體提供新的治療途徑。</a:t>
+              <a:t>   傳統藥用蘑菇如Sanghuangporus vaninii在治療結腸炎相關結直腸癌中的潛力，突顯了傳統與現代治療方法整合的重要性。</a:t>
             </a:r>
             <a:endParaRPr lang="en-US" sz="1000" dirty="0"/>
           </a:p>
@@ -11724,7 +11724,7 @@
                   <a:srgbClr val="E8F0F2"/>
                 </a:solidFill>
               </a:rPr>
-              <a:t>1. **深入探討腫瘤微環境的角色**  </a:t>
+              <a:t>1. **深入探討炎症與癌症的機制**  </a:t>
             </a:r>
             <a:endParaRPr lang="en-US" sz="1000" dirty="0"/>
           </a:p>
@@ -11741,7 +11741,7 @@
                   <a:srgbClr val="E8F0F2"/>
                 </a:solidFill>
               </a:rPr>
-              <a:t>   Future studies should focus on elucidating the specific mechanisms by which the tumor microenvironment influences metastatic behavior in colorectal cancer.  </a:t>
+              <a:t>   Future studies should focus on elucidating the mechanisms by which systemic inflammation influences colorectal cancer progression and metastasis.  </a:t>
             </a:r>
             <a:endParaRPr lang="en-US" sz="1000" dirty="0"/>
           </a:p>
@@ -11758,7 +11758,7 @@
                   <a:srgbClr val="E8F0F2"/>
                 </a:solidFill>
               </a:rPr>
-              <a:t>   未來的研究應集中於闡明腫瘤微環境如何影響大腸癌的轉移行為的具體機制。</a:t>
+              <a:t>   未來的研究應集中於闡明系統性炎症如何影響結直腸癌的進展和轉移的機制。</a:t>
             </a:r>
             <a:endParaRPr lang="en-US" sz="1000" dirty="0"/>
           </a:p>
@@ -11784,7 +11784,7 @@
                   <a:srgbClr val="E8F0F2"/>
                 </a:solidFill>
               </a:rPr>
-              <a:t>2. **擴大系統性免疫炎症指數的應用研究**  </a:t>
+              <a:t>2. **微生物群的調節策略**  </a:t>
             </a:r>
             <a:endParaRPr lang="en-US" sz="1000" dirty="0"/>
           </a:p>
@@ -11801,7 +11801,7 @@
                   <a:srgbClr val="E8F0F2"/>
                 </a:solidFill>
               </a:rPr>
-              <a:t>   Expanding research on the application of the systemic immune-inflammation index across diverse patient populations may enhance its prognostic utility.  </a:t>
+              <a:t>   Investigating the modulation of gut microbiota as a therapeutic strategy for colorectal cancer could provide new avenues for treatment.  </a:t>
             </a:r>
             <a:endParaRPr lang="en-US" sz="1000" dirty="0"/>
           </a:p>
@@ -11818,7 +11818,7 @@
                   <a:srgbClr val="E8F0F2"/>
                 </a:solidFill>
               </a:rPr>
-              <a:t>   擴大系統性免疫炎症指數在不同患者群體中的應用研究，可能會增強其預後價值。</a:t>
+              <a:t>   探討調節腸道微生物群作為結直腸癌治療策略的可能性，可能為治療提供新的途徑。</a:t>
             </a:r>
             <a:endParaRPr lang="en-US" sz="1000" dirty="0"/>
           </a:p>
@@ -11844,7 +11844,7 @@
                   <a:srgbClr val="E8F0F2"/>
                 </a:solidFill>
               </a:rPr>
-              <a:t>3. **提高患者對癌症風險的認知**  </a:t>
+              <a:t>3. **新型生物標記的發掘**  </a:t>
             </a:r>
             <a:endParaRPr lang="en-US" sz="1000" dirty="0"/>
           </a:p>
@@ -11861,7 +11861,7 @@
                   <a:srgbClr val="E8F0F2"/>
                 </a:solidFill>
               </a:rPr>
-              <a:t>   Interventions aimed at improving awareness and understanding of colorectal cancer risks among patients with inflammatory bowel disease should be developed and tested.  </a:t>
+              <a:t>   Continued research into novel biomarkers for early detection and prognosis of colorectal cancer is essential for improving patient outcomes.  </a:t>
             </a:r>
             <a:endParaRPr lang="en-US" sz="1000" dirty="0"/>
           </a:p>
@@ -11878,7 +11878,7 @@
                   <a:srgbClr val="E8F0F2"/>
                 </a:solidFill>
               </a:rPr>
-              <a:t>   應開發和測試旨在提高炎症性腸病患者對大腸癌風險認知的干預措施。</a:t>
+              <a:t>   持續研究新型生物標記以便於結直腸癌的早期檢測和預後，對改善患者預後至關重要。</a:t>
             </a:r>
             <a:endParaRPr lang="en-US" sz="1000" dirty="0"/>
           </a:p>
@@ -11904,7 +11904,7 @@
                   <a:srgbClr val="E8F0F2"/>
                 </a:solidFill>
               </a:rPr>
-              <a:t>4. **探索新療法的臨床試驗**  </a:t>
+              <a:t>4. **抗炎療法的臨床試驗**  </a:t>
             </a:r>
             <a:endParaRPr lang="en-US" sz="1000" dirty="0"/>
           </a:p>
@@ -11921,7 +11921,7 @@
                   <a:srgbClr val="E8F0F2"/>
                 </a:solidFill>
               </a:rPr>
-              <a:t>   Clinical trials evaluating the efficacy and safety of emerging therapies targeting inflammation in colorectal cancer are warranted to validate their therapeutic potential.  </a:t>
+              <a:t>   Clinical trials assessing the efficacy of anti-inflammatory therapies in patients with colitis-associated colorectal cancer should be prioritized.  </a:t>
             </a:r>
             <a:endParaRPr lang="en-US" sz="1000" dirty="0"/>
           </a:p>
@@ -11938,7 +11938,7 @@
                   <a:srgbClr val="E8F0F2"/>
                 </a:solidFill>
               </a:rPr>
-              <a:t>   需要進行臨床試驗以評估針對大腸癌炎症的新療法的有效性和安全性，以驗證其治療潛力。</a:t>
+              <a:t>   應優先進行臨床試驗，以評估抗炎療法在結腸炎相關結直腸癌患者中的療效。</a:t>
             </a:r>
             <a:endParaRPr lang="en-US" sz="1000" dirty="0"/>
           </a:p>
@@ -11964,7 +11964,7 @@
                   <a:srgbClr val="E8F0F2"/>
                 </a:solidFill>
               </a:rPr>
-              <a:t>5. **PARP抑制劑的分子標記研究**  </a:t>
+              <a:t>5. **多學科合作的研究模式**  </a:t>
             </a:r>
             <a:endParaRPr lang="en-US" sz="1000" dirty="0"/>
           </a:p>
@@ -11981,7 +11981,7 @@
                   <a:srgbClr val="E8F0F2"/>
                 </a:solidFill>
               </a:rPr>
-              <a:t>   Investigating molecular markers that predict response to PARP inhibitors in peritoneal metastatic colorectal cancer could refine patient selection for targeted therapies.  </a:t>
+              <a:t>   Promoting multidisciplinary approaches that integrate oncology, immunology, and microbiology could enhance our understanding and treatment of colorectal cancer.  </a:t>
             </a:r>
             <a:endParaRPr lang="en-US" sz="1000" dirty="0"/>
           </a:p>
@@ -11998,7 +11998,7 @@
                   <a:srgbClr val="E8F0F2"/>
                 </a:solidFill>
               </a:rPr>
-              <a:t>   研究預測腹膜轉移性大腸癌對PARP抑制劑反應的分子標記，可能會精細化針對性治療的患者選擇。</a:t>
+              <a:t>   促進整合腫瘤學、免疫學和微生物學的多學科研究模式，可能增強我們對結直腸癌的理解和治療。</a:t>
             </a:r>
             <a:endParaRPr lang="en-US" sz="1000" dirty="0"/>
           </a:p>
@@ -12607,7 +12607,7 @@
                 <a:ea typeface="Arial" pitchFamily="34" charset="-122"/>
                 <a:cs typeface="Arial" pitchFamily="34" charset="-120"/>
               </a:rPr>
-              <a:t>The ORCHESTRA trial did not demonstrate a significant benefit of debulking surgery in patients with metastatic colorectal cancer.</a:t>
+              <a:t>The ORCHESTRA trial found no significant benefit of debulking surgery in patients with metastatic colorectal cancer.</a:t>
             </a:r>
             <a:endParaRPr lang="en-US" sz="1000" dirty="0"/>
           </a:p>
@@ -12628,7 +12628,7 @@
                 <a:ea typeface="Arial" pitchFamily="34" charset="-122"/>
                 <a:cs typeface="Arial" pitchFamily="34" charset="-120"/>
               </a:rPr>
-              <a:t>Patients with resectable liver metastases showed no improvement in overall survival with surgical intervention.</a:t>
+              <a:t>Patients with resectable liver metastases showed similar outcomes whether they underwent surgery or not.</a:t>
             </a:r>
             <a:endParaRPr lang="en-US" sz="1000" dirty="0"/>
           </a:p>
@@ -12649,7 +12649,7 @@
                 <a:ea typeface="Arial" pitchFamily="34" charset="-122"/>
                 <a:cs typeface="Arial" pitchFamily="34" charset="-120"/>
               </a:rPr>
-              <a:t>The findings challenge the current paradigm of aggressive surgical approaches in metastatic colorectal cancer management.</a:t>
+              <a:t>The study raises concerns about the efficacy of surgical intervention for colorectal peritoneal and pulmonary metastases.</a:t>
             </a:r>
             <a:endParaRPr lang="en-US" sz="1000" dirty="0"/>
           </a:p>
@@ -12731,7 +12731,7 @@
                 <a:ea typeface="Microsoft JhengHei" pitchFamily="34" charset="-122"/>
                 <a:cs typeface="Microsoft JhengHei" pitchFamily="34" charset="-120"/>
               </a:rPr>
-              <a:t>ORCHESTRA 試驗未顯示在轉移性結直腸癌患者中，減瘤手術有顯著益處。</a:t>
+              <a:t>ORCHESTRA 試驗發現，對於轉移性結直腸癌患者，減瘤手術並未顯著改善預後。</a:t>
             </a:r>
             <a:endParaRPr lang="en-US" sz="1000" dirty="0"/>
           </a:p>
@@ -12752,7 +12752,7 @@
                 <a:ea typeface="Microsoft JhengHei" pitchFamily="34" charset="-122"/>
                 <a:cs typeface="Microsoft JhengHei" pitchFamily="34" charset="-120"/>
               </a:rPr>
-              <a:t>有可切除肝轉移的患者在手術介入後整體生存率未見改善。</a:t>
+              <a:t>對於可切除的肝轉移患者，無論是否接受手術，結果相似。</a:t>
             </a:r>
             <a:endParaRPr lang="en-US" sz="1000" dirty="0"/>
           </a:p>
@@ -12773,7 +12773,7 @@
                 <a:ea typeface="Microsoft JhengHei" pitchFamily="34" charset="-122"/>
                 <a:cs typeface="Microsoft JhengHei" pitchFamily="34" charset="-120"/>
               </a:rPr>
-              <a:t>這些發現挑戰了目前對轉移性結直腸癌管理中積極手術方法的認知。</a:t>
+              <a:t>該研究對結直腸腹膜和肺轉移的外科介入效果提出了疑慮。</a:t>
             </a:r>
             <a:endParaRPr lang="en-US" sz="1000" dirty="0"/>
           </a:p>
@@ -13106,7 +13106,7 @@
                   <a:srgbClr val="1A2332"/>
                 </a:solidFill>
               </a:rPr>
-              <a:t>EN: The results suggest that debulking surgery may not be beneficial for all patients with metastatic colorectal cancer, particularly those with liver metastases. </a:t>
+              <a:t>EN: The findings suggest that debulking surgery may not be beneficial for all patients with metastatic colorectal cancer, indicating a need for careful patient selection. </a:t>
             </a:r>
             <a:endParaRPr lang="en-US" sz="1000" dirty="0"/>
           </a:p>
@@ -13123,7 +13123,7 @@
                   <a:srgbClr val="1A2332"/>
                 </a:solidFill>
               </a:rPr>
-              <a:t>ZH: 這些結果表明，減瘤手術對於所有轉移性結直腸癌患者可能並不有利，特別是對於肝轉移患者。</a:t>
+              <a:t>ZH: 這些發現表明，減瘤手術對於所有轉移性結直腸癌患者可能並無益處，這需要謹慎選擇患者。</a:t>
             </a:r>
             <a:endParaRPr lang="en-US" sz="1000" dirty="0"/>
           </a:p>
@@ -13266,7 +13266,7 @@
                   <a:srgbClr val="1A2332"/>
                 </a:solidFill>
               </a:rPr>
-              <a:t>EN: Future research should focus on identifying specific patient populations that may still benefit from surgical intervention. </a:t>
+              <a:t>EN: Future research should focus on identifying specific patient populations that may benefit from surgical intervention in metastatic colorectal cancer. </a:t>
             </a:r>
             <a:endParaRPr lang="en-US" sz="1000" dirty="0"/>
           </a:p>
@@ -13283,7 +13283,7 @@
                   <a:srgbClr val="1A2332"/>
                 </a:solidFill>
               </a:rPr>
-              <a:t>ZH: 未來的研究應著重於識別仍可能從手術介入中受益的特定患者群體。</a:t>
+              <a:t>ZH: 未來的研究應著重於確定在轉移性結直腸癌中可能受益於外科介入的特定患者群體。</a:t>
             </a:r>
             <a:endParaRPr lang="en-US" sz="1000" dirty="0"/>
           </a:p>
@@ -13630,7 +13630,7 @@
                 <a:ea typeface="Arial" pitchFamily="34" charset="-122"/>
                 <a:cs typeface="Arial" pitchFamily="34" charset="-120"/>
               </a:rPr>
-              <a:t>Parasutterella excrementihominis (P. excrementihominis) is shown to exacerbate experimental colitis.</a:t>
+              <a:t>Parasutterella excrementihominis (P. excrementihominis) exacerbates experimental colitis.</a:t>
             </a:r>
             <a:endParaRPr lang="en-US" sz="1000" dirty="0"/>
           </a:p>
@@ -13651,7 +13651,7 @@
                 <a:ea typeface="Arial" pitchFamily="34" charset="-122"/>
                 <a:cs typeface="Arial" pitchFamily="34" charset="-120"/>
               </a:rPr>
-              <a:t>The study identifies a link between P. excrementihominis and the activation of pathogenic NETosis.</a:t>
+              <a:t>The study highlights the role of pathogenic NETosis activation in colitis-associated colorectal cancer.</a:t>
             </a:r>
             <a:endParaRPr lang="en-US" sz="1000" dirty="0"/>
           </a:p>
@@ -13672,7 +13672,7 @@
                 <a:ea typeface="Arial" pitchFamily="34" charset="-122"/>
                 <a:cs typeface="Arial" pitchFamily="34" charset="-120"/>
               </a:rPr>
-              <a:t>Colitis-associated colorectal cancer is significantly influenced by the presence of P. excrementihominis.</a:t>
+              <a:t>Targeting the P. excrementihominis axis may provide new therapeutic strategies for inflammation-driven colorectal carcinogenesis.</a:t>
             </a:r>
             <a:endParaRPr lang="en-US" sz="1000" dirty="0"/>
           </a:p>
@@ -13754,7 +13754,7 @@
                 <a:ea typeface="Microsoft JhengHei" pitchFamily="34" charset="-122"/>
                 <a:cs typeface="Microsoft JhengHei" pitchFamily="34" charset="-120"/>
               </a:rPr>
-              <a:t>Parasutterella excrementihominis (P. excrementihominis) 被證實會加重實驗性結腸炎。</a:t>
+              <a:t>寄生性大腸桿菌（P. excrementihominis）加重了實驗性結腸炎。</a:t>
             </a:r>
             <a:endParaRPr lang="en-US" sz="1000" dirty="0"/>
           </a:p>
@@ -13775,7 +13775,7 @@
                 <a:ea typeface="Microsoft JhengHei" pitchFamily="34" charset="-122"/>
                 <a:cs typeface="Microsoft JhengHei" pitchFamily="34" charset="-120"/>
               </a:rPr>
-              <a:t>本研究確定了 P. excrementihominis 與致病性 NETosis 活化之間的聯繫。</a:t>
+              <a:t>研究強調了病理性NETosis活化在結腸炎相關結直腸癌中的作用。</a:t>
             </a:r>
             <a:endParaRPr lang="en-US" sz="1000" dirty="0"/>
           </a:p>
@@ -13796,7 +13796,7 @@
                 <a:ea typeface="Microsoft JhengHei" pitchFamily="34" charset="-122"/>
                 <a:cs typeface="Microsoft JhengHei" pitchFamily="34" charset="-120"/>
               </a:rPr>
-              <a:t>結腸炎相關的結直腸癌受到 P. excrementihominis 存在的顯著影響。</a:t>
+              <a:t>針對P. excrementihominis軸可能為炎症驅動的結直腸癌提供新的治療策略。</a:t>
             </a:r>
             <a:endParaRPr lang="en-US" sz="1000" dirty="0"/>
           </a:p>
@@ -14129,7 +14129,7 @@
                   <a:srgbClr val="1A2332"/>
                 </a:solidFill>
               </a:rPr>
-              <a:t>EN: The findings suggest that targeting P. excrementihominis may provide a new therapeutic approach for managing colitis and preventing colorectal cancer. </a:t>
+              <a:t>EN: The findings suggest that targeting P. excrementihominis may help mitigate colitis and reduce the risk of colorectal cancer. </a:t>
             </a:r>
             <a:endParaRPr lang="en-US" sz="1000" dirty="0"/>
           </a:p>
@@ -14146,7 +14146,7 @@
                   <a:srgbClr val="1A2332"/>
                 </a:solidFill>
               </a:rPr>
-              <a:t>ZH: 研究結果表明，針對 P. excrementihominis 可能為管理結腸炎和預防結直腸癌提供新的治療方法。</a:t>
+              <a:t>ZH: 研究結果表明，針對P. excrementihominis可能有助於減輕結腸炎並降低結直腸癌的風險。</a:t>
             </a:r>
             <a:endParaRPr lang="en-US" sz="1000" dirty="0"/>
           </a:p>
@@ -14289,7 +14289,7 @@
                   <a:srgbClr val="1A2332"/>
                 </a:solidFill>
               </a:rPr>
-              <a:t>EN: Future research should focus on the mechanisms by which P. excrementihominis activates NETosis and its role in cancer progression. </a:t>
+              <a:t>EN: Future studies should explore the mechanisms of NETosis in greater detail and evaluate potential therapeutic interventions. </a:t>
             </a:r>
             <a:endParaRPr lang="en-US" sz="1000" dirty="0"/>
           </a:p>
@@ -14306,7 +14306,7 @@
                   <a:srgbClr val="1A2332"/>
                 </a:solidFill>
               </a:rPr>
-              <a:t>ZH: 未來的研究應集中於 P. excrementihominis 如何激活 NETosis 及其在癌症進展中的作用機制。</a:t>
+              <a:t>ZH: 未來的研究應更詳細地探討NETosis的機制並評估潛在的治療干預措施。</a:t>
             </a:r>
             <a:endParaRPr lang="en-US" sz="1000" dirty="0"/>
           </a:p>
@@ -14653,7 +14653,7 @@
                 <a:ea typeface="Arial" pitchFamily="34" charset="-122"/>
                 <a:cs typeface="Arial" pitchFamily="34" charset="-120"/>
               </a:rPr>
-              <a:t>The systemic immune-inflammation index (SII) is identified as a promising prognostic biomarker for colorectal cancer (CRC).</a:t>
+              <a:t>The systemic immune-inflammation index (SII) is identified as a significant prognostic biomarker for colorectal cancer (CRC).</a:t>
             </a:r>
             <a:endParaRPr lang="en-US" sz="1000" dirty="0"/>
           </a:p>
@@ -14674,7 +14674,7 @@
                 <a:ea typeface="Arial" pitchFamily="34" charset="-122"/>
                 <a:cs typeface="Arial" pitchFamily="34" charset="-120"/>
               </a:rPr>
-              <a:t>Higher SII values are associated with poorer overall survival and disease-free survival in CRC patients.</a:t>
+              <a:t>Higher SII values correlate with poorer overall survival and disease-free survival in CRC patients.</a:t>
             </a:r>
             <a:endParaRPr lang="en-US" sz="1000" dirty="0"/>
           </a:p>
@@ -14695,7 +14695,7 @@
                 <a:ea typeface="Arial" pitchFamily="34" charset="-122"/>
                 <a:cs typeface="Arial" pitchFamily="34" charset="-120"/>
               </a:rPr>
-              <a:t>The meta-analysis included multiple studies, reinforcing the reliability of SII as a prognostic tool.</a:t>
+              <a:t>This systematic review and meta-analysis consolidate existing data, enhancing the understanding of SII's role in CRC prognosis.</a:t>
             </a:r>
             <a:endParaRPr lang="en-US" sz="1000" dirty="0"/>
           </a:p>
@@ -14777,7 +14777,7 @@
                 <a:ea typeface="Microsoft JhengHei" pitchFamily="34" charset="-122"/>
                 <a:cs typeface="Microsoft JhengHei" pitchFamily="34" charset="-120"/>
               </a:rPr>
-              <a:t>系統免疫炎症指數（SII）被認為是大腸癌（CRC）有前景的預後生物標誌物。</a:t>
+              <a:t>系統免疫炎症指數（SII）被確定為結直腸癌（CRC）的重要預後生物標誌物。</a:t>
             </a:r>
             <a:endParaRPr lang="en-US" sz="1000" dirty="0"/>
           </a:p>
@@ -14819,7 +14819,7 @@
                 <a:ea typeface="Microsoft JhengHei" pitchFamily="34" charset="-122"/>
                 <a:cs typeface="Microsoft JhengHei" pitchFamily="34" charset="-120"/>
               </a:rPr>
-              <a:t>這項綜合分析納入了多項研究，增強了SII作為預後工具的可靠性。</a:t>
+              <a:t>這項系統評價和荟萃分析整合了現有數據，增強了對SII在CRC預後中作用的理解。</a:t>
             </a:r>
             <a:endParaRPr lang="en-US" sz="1000" dirty="0"/>
           </a:p>
@@ -15152,7 +15152,7 @@
                   <a:srgbClr val="1A2332"/>
                 </a:solidFill>
               </a:rPr>
-              <a:t>EN: The findings suggest that SII could be utilized in clinical practice to stratify CRC patients based on their prognosis. </a:t>
+              <a:t>EN: The findings suggest that SII can be utilized as a reliable prognostic tool in clinical practice for CRC patients. </a:t>
             </a:r>
             <a:endParaRPr lang="en-US" sz="1000" dirty="0"/>
           </a:p>
@@ -15169,7 +15169,7 @@
                   <a:srgbClr val="1A2332"/>
                 </a:solidFill>
               </a:rPr>
-              <a:t>ZH: 研究結果表明，SII可以在臨床實踐中用來根據預後對CRC患者進行分層。</a:t>
+              <a:t>ZH: 研究結果表明，SII可以作為結直腸癌患者臨床實踐中的可靠預後工具。</a:t>
             </a:r>
             <a:endParaRPr lang="en-US" sz="1000" dirty="0"/>
           </a:p>
@@ -15312,7 +15312,7 @@
                   <a:srgbClr val="1A2332"/>
                 </a:solidFill>
               </a:rPr>
-              <a:t>EN: Future research should focus on validating SII in diverse populations and exploring its role in guiding treatment decisions. </a:t>
+              <a:t>EN: Future studies should focus on the integration of SII with other biomarkers to improve prognostic accuracy. </a:t>
             </a:r>
             <a:endParaRPr lang="en-US" sz="1000" dirty="0"/>
           </a:p>
@@ -15329,7 +15329,7 @@
                   <a:srgbClr val="1A2332"/>
                 </a:solidFill>
               </a:rPr>
-              <a:t>ZH: 未來的研究應著重於在不同人群中驗證SII，並探討其在指導治療決策中的作用。</a:t>
+              <a:t>ZH: 未來的研究應集中於將SII與其他生物標誌物整合，以提高預後準確性。</a:t>
             </a:r>
             <a:endParaRPr lang="en-US" sz="1000" dirty="0"/>
           </a:p>
@@ -15718,7 +15718,7 @@
                 <a:ea typeface="Arial" pitchFamily="34" charset="-122"/>
                 <a:cs typeface="Arial" pitchFamily="34" charset="-120"/>
               </a:rPr>
-              <a:t>Current literature highlights the need for improved education and communication about colorectal cancer risks in IBD.</a:t>
+              <a:t>Current literature indicates a need for improved education and communication about colorectal cancer risks in IBD populations.</a:t>
             </a:r>
             <a:endParaRPr lang="en-US" sz="1000" dirty="0"/>
           </a:p>
@@ -15800,7 +15800,7 @@
                 <a:ea typeface="Microsoft JhengHei" pitchFamily="34" charset="-122"/>
                 <a:cs typeface="Microsoft JhengHei" pitchFamily="34" charset="-120"/>
               </a:rPr>
-              <a:t>炎症性腸病（IBD）患者罹患結腸直腸癌的風險較高。</a:t>
+              <a:t>炎症性腸病（IBD）患者罹患大腸癌的風險較高。</a:t>
             </a:r>
             <a:endParaRPr lang="en-US" sz="1000" dirty="0"/>
           </a:p>
@@ -15842,7 +15842,7 @@
                 <a:ea typeface="Microsoft JhengHei" pitchFamily="34" charset="-122"/>
                 <a:cs typeface="Microsoft JhengHei" pitchFamily="34" charset="-120"/>
               </a:rPr>
-              <a:t>現有文獻強調需要改善對IBD患者結腸直腸癌風險的教育和溝通。</a:t>
+              <a:t>現有文獻顯示需要改善對IBD人群大腸癌風險的教育和溝通。</a:t>
             </a:r>
             <a:endParaRPr lang="en-US" sz="1000" dirty="0"/>
           </a:p>

</xml_diff>